<commit_message>
Align presentation claims with the camera-ready paper
Add the Ridge + F_all row to the results table so the 77.48 / 32.62
figures can be traced, and label the 20.57 pp gap as best versus best
next to the same-counter gap of 21.63 pp. State that the 3.19 pp
counter spread refers to detector boxes with F0 features.

Reword statements that went beyond the paper: prior oil palm work,
the fixed detector, counters fitted per input condition, and the
conclusion on detector priority. Drop the smartphone wording, which
the paper does not state.
</commit_message>
<xml_diff>
--- a/draft-icic-2026/presentation/057_MUTTAQIN.pptx
+++ b/draft-icic-2026/presentation/057_MUTTAQIN.pptx
@@ -658,12 +658,12 @@
           <a:lstStyle/>
           <a:p>
             <a:r>
-              <a:t>Other researchers have solved this for mango and apple, but their methods need a camera that moves along the row or many overlapping images. We only have four separate smartphone photos per tree.</a:t>
-            </a:r>
-          </a:p>
-          <a:p>
-            <a:r>
-              <a:t>For oil palm, earlier work stops at detecting bunches in a single image. And when a counting system is tested, it is tested as a whole, so nobody can tell which of the two parts made the mistake.</a:t>
+              <a:t>Other researchers have studied multi-view counting for mango and apple, but their methods rely on a moving sensor, many overlapping images or calibrated cameras. We only have four separate photos per tree.</a:t>
+            </a:r>
+          </a:p>
+          <a:p>
+            <a:r>
+              <a:t>For oil palm, detecting the bunches is still difficult, and the public dataset does not give a count per tree. Also, when a counting system is tested only on the boxes from a detector, the mistakes of the detector and the mistakes of the counter are mixed together.</a:t>
             </a:r>
           </a:p>
         </p:txBody>
@@ -733,12 +733,12 @@
           <a:lstStyle/>
           <a:p>
             <a:r>
-              <a:t>To separate the two parts, we test every counter twice. The first time, we give it the boxes that experts drew by hand, so the input has no mistakes. The second time, we give it the boxes from a YOLO detector, which misses some bunches and gives some of them the wrong class.</a:t>
-            </a:r>
-          </a:p>
-          <a:p>
-            <a:r>
-              <a:t>We use one detector model for the whole study and we never retrain it, so every counter receives exactly the same boxes. Because the counter is also the same in both tests, any drop in accuracy comes from the mistakes of the detector.</a:t>
+              <a:t>To separate the two parts, we test every counting method twice. The first time, we give it the boxes that experts drew by hand, which we treat as correct. The second time, we give it the boxes from a YOLO detector, which misses some bunches and gives some of them the wrong class.</a:t>
+            </a:r>
+          </a:p>
+          <a:p>
+            <a:r>
+              <a:t>In the main experiments we use one detector model and we keep it fixed, so every counter receives exactly the same boxes. Because the counting method is also the same in both tests, the drop in accuracy shows the effect of the detector's mistakes.</a:t>
             </a:r>
           </a:p>
           <a:p>
@@ -813,22 +813,22 @@
           <a:lstStyle/>
           <a:p>
             <a:r>
-              <a:t>This slide has all our results, so let me point to the main numbers. With the expert boxes, the best counter is correct in 98 percent of the cases. With the detector boxes, it drops to 77 percent. That is a loss of about 21 points.</a:t>
-            </a:r>
-          </a:p>
-          <a:p>
-            <a:r>
-              <a:t>In contrast, when we compare the five counters with each other, they differ by only 3 points, and that difference is not statistically significant.</a:t>
-            </a:r>
-          </a:p>
-          <a:p>
-            <a:r>
-              <a:t>Why is the loss so large? Because 23 percent of the bunches are not detected in any of the photos, and the counter cannot count a bunch that it never receives. The detector also often labels B2 bunches as B3.</a:t>
-            </a:r>
-          </a:p>
-          <a:p>
-            <a:r>
-              <a:t>Giving the counter more information improved it by only about one point. And when we repeated the comparison with another detector and with cross-validation, the gap stayed between 23 and 25 points.</a:t>
+              <a:t>This slide has all our results, so let me point to the main numbers. With the expert boxes, the best result is 98 percent. With the detector boxes, the best result is 77 percent. That is a gap of about 21 points.</a:t>
+            </a:r>
+          </a:p>
+          <a:p>
+            <a:r>
+              <a:t>In contrast, when we compare the five regression counters with each other on the detector boxes, they differ by only 3 points, and that difference is not statistically significant.</a:t>
+            </a:r>
+          </a:p>
+          <a:p>
+            <a:r>
+              <a:t>Where does the gap come from? 23 percent of the bunches are not detected in any of the photos, and the counter has no information about a bunch that is never detected. The detector also often labels B2 bunches as B3.</a:t>
+            </a:r>
+          </a:p>
+          <a:p>
+            <a:r>
+              <a:t>Giving the counter more information improved it by only 1.4 points, which is not significant. And when we repeated the comparison with another detector and with cross-validation, the gap was still 23 to 25 points.</a:t>
             </a:r>
           </a:p>
         </p:txBody>
@@ -898,17 +898,17 @@
           <a:lstStyle/>
           <a:p>
             <a:r>
-              <a:t>So, to answer our question: on this dataset, the count depends much more on the detector than on the choice of counter. The next improvement should therefore be in the detector, especially for the unripe classes B3 and B4.</a:t>
-            </a:r>
-          </a:p>
-          <a:p>
-            <a:r>
-              <a:t>We also suggest that counting methods be reported with both expert boxes and detector boxes, so that the two sources of error stay visible.</a:t>
-            </a:r>
-          </a:p>
-          <a:p>
-            <a:r>
-              <a:t>Our data come from only two estates, so we still need to test this on an independent plantation.</a:t>
+              <a:t>So, to answer our question: on this dataset, the quality of the boxes changed the accuracy much more than the choice of counter. Our results therefore support improving the detector first, especially for the unripe classes B3 and B4.</a:t>
+            </a:r>
+          </a:p>
+          <a:p>
+            <a:r>
+              <a:t>We also suggest that counting methods be reported with both expert boxes and detector boxes, so that the effect of the detector stays visible.</a:t>
+            </a:r>
+          </a:p>
+          <a:p>
+            <a:r>
+              <a:t>Our data come from only two estates, so we still need to test this on an independent plantation. We also do not claim that the counter cannot be improved.</a:t>
             </a:r>
           </a:p>
         </p:txBody>
@@ -5782,7 +5782,7 @@
               </a:spcAft>
             </a:pPr>
             <a:r>
-              <a:rPr sz="1900" b="1">
+              <a:rPr sz="1700" b="1">
                 <a:solidFill>
                   <a:srgbClr val="C8511B"/>
                 </a:solidFill>
@@ -5801,13 +5801,13 @@
               </a:spcAft>
             </a:pPr>
             <a:r>
-              <a:rPr sz="950" b="0">
+              <a:rPr sz="900" b="0">
                 <a:solidFill>
                   <a:srgbClr val="1E2B24"/>
                 </a:solidFill>
                 <a:latin typeface="Calibri"/>
               </a:rPr>
-              <a:t>average number of photos in which one bunch appears</a:t>
+              <a:t>average number of photos in which one bunch appears (716 training trees)</a:t>
             </a:r>
           </a:p>
         </p:txBody>
@@ -5889,7 +5889,7 @@
               </a:spcAft>
             </a:pPr>
             <a:r>
-              <a:rPr sz="1900" b="1">
+              <a:rPr sz="1700" b="1">
                 <a:solidFill>
                   <a:srgbClr val="C8511B"/>
                 </a:solidFill>
@@ -5908,13 +5908,13 @@
               </a:spcAft>
             </a:pPr>
             <a:r>
-              <a:rPr sz="950" b="0">
+              <a:rPr sz="900" b="0">
                 <a:solidFill>
                   <a:srgbClr val="1E2B24"/>
                 </a:solidFill>
                 <a:latin typeface="Calibri"/>
               </a:rPr>
-              <a:t>of the class counts are right when all boxes are simply added up</a:t>
+              <a:t>of class counts are within one bunch of the truth when all expert boxes are simply added up</a:t>
             </a:r>
           </a:p>
         </p:txBody>
@@ -7555,7 +7555,7 @@
                           </a:solidFill>
                           <a:latin typeface="Calibri"/>
                         </a:rPr>
-                        <a:t>Needs dense image overlap along the row</a:t>
+                        <a:t>Needs dense image overlap</a:t>
                       </a:r>
                     </a:p>
                   </a:txBody>
@@ -7815,7 +7815,7 @@
                           </a:solidFill>
                           <a:latin typeface="Calibri"/>
                         </a:rPr>
-                        <a:t>Per-image detection only; occluded bunches and similar classes stay difficult</a:t>
+                        <a:t>Detection is still difficult for occluded bunches and similar maturity classes</a:t>
                       </a:r>
                     </a:p>
                   </a:txBody>
@@ -7945,7 +7945,7 @@
                           </a:solidFill>
                           <a:latin typeface="Calibri"/>
                         </a:rPr>
-                        <a:t>No tree-level counting labels, no counting evaluation</a:t>
+                        <a:t>No tree-level counting labels, no reported counting evaluation</a:t>
                       </a:r>
                     </a:p>
                   </a:txBody>
@@ -8043,7 +8043,7 @@
                           </a:solidFill>
                           <a:latin typeface="Calibri"/>
                         </a:rPr>
-                        <a:t>Regression counters on detection statistics from 4 to 8 smartphone views per tree, scored on ground-truth boxes and on detector boxes</a:t>
+                        <a:t>Regression counters on detection statistics from 4 to 8 views per tree, scored on ground-truth boxes and on detector boxes</a:t>
                       </a:r>
                     </a:p>
                   </a:txBody>
@@ -8216,7 +8216,7 @@
                 </a:solidFill>
                 <a:latin typeface="Calibri"/>
               </a:rPr>
-              <a:t>Existing multi-view methods need dense overlap, a moving sensor or calibrated cameras. A field survey gives only 4 to 8 separate photos per tree.</a:t>
+              <a:t>Existing multi-view methods rely on dense overlap, moving sensors or calibrated geometry. Our survey gives 4 to 8 separate photos per tree.</a:t>
             </a:r>
           </a:p>
           <a:p>
@@ -8236,7 +8236,7 @@
                 </a:solidFill>
                 <a:latin typeface="Calibri"/>
               </a:rPr>
-              <a:t>Oil palm studies stop at detection in single images; the public dataset has no count per tree.</a:t>
+              <a:t>For oil palm, detection is still difficult, and the public dataset has no tree-level counting labels.</a:t>
             </a:r>
           </a:p>
           <a:p>
@@ -8256,7 +8256,7 @@
                 </a:solidFill>
                 <a:latin typeface="Calibri"/>
               </a:rPr>
-              <a:t>Counting systems are tested as a whole, on detector boxes only, so the errors of the detector and of the counter cannot be separated.</a:t>
+              <a:t>Testing a counting system only on detector boxes mixes the errors of the detector and of the counter.</a:t>
             </a:r>
           </a:p>
         </p:txBody>
@@ -8407,7 +8407,7 @@
                 </a:solidFill>
                 <a:latin typeface="Calibri"/>
               </a:rPr>
-              <a:t>Each counter is tested twice: on boxes drawn by experts (ground truth) and on the boxes of one YOLO26m detector that is never retrained.</a:t>
+              <a:t>Each counter is tested twice: on boxes drawn by experts (ground truth) and on the boxes of one YOLO26m detector that is kept fixed.</a:t>
             </a:r>
           </a:p>
           <a:p>
@@ -8840,7 +8840,7 @@
                 </a:solidFill>
                 <a:latin typeface="Calibri"/>
               </a:rPr>
-              <a:t>Boxes and classes drawn by experts. </a:t>
+              <a:t>Boxes and classes drawn by experts, </a:t>
             </a:r>
             <a:r>
               <a:rPr sz="850" b="0">
@@ -8849,7 +8849,16 @@
                 </a:solidFill>
                 <a:latin typeface="Calibri"/>
               </a:rPr>
-              <a:t>Every bunch is found and every class is correct.</a:t>
+              <a:t>treated as correct.</a:t>
+            </a:r>
+            <a:r>
+              <a:rPr sz="850" b="0">
+                <a:solidFill>
+                  <a:srgbClr val="5B6B62"/>
+                </a:solidFill>
+                <a:latin typeface="Calibri"/>
+              </a:rPr>
+              <a:t> Test tree DAMIMAS_A21B_0139, side 2.</a:t>
             </a:r>
           </a:p>
         </p:txBody>
@@ -9004,7 +9013,7 @@
                 </a:solidFill>
                 <a:latin typeface="Calibri"/>
               </a:rPr>
-              <a:t>One YOLO26m model, trained on 716 trees and never retrained. </a:t>
+              <a:t>One YOLO26m model, trained once on 716 trees and kept fixed. </a:t>
             </a:r>
             <a:r>
               <a:rPr sz="850" b="0">
@@ -9013,7 +9022,7 @@
                 </a:solidFill>
                 <a:latin typeface="Calibri"/>
               </a:rPr>
-              <a:t>It misses bunches, swaps classes and duplicates boxes.</a:t>
+              <a:t>Real output on the same photo: a missed bunch, a wrong class, a duplicate box.</a:t>
             </a:r>
           </a:p>
         </p:txBody>
@@ -9299,11 +9308,11 @@
         <p:spPr>
           <a:xfrm>
             <a:off x="3246120" y="1883664"/>
-            <a:ext cx="5577840" cy="1060704"/>
+            <a:ext cx="5577840" cy="1133856"/>
           </a:xfrm>
           <a:prstGeom prst="roundRect">
             <a:avLst>
-              <a:gd name="adj" fmla="val 5172"/>
+              <a:gd name="adj" fmla="val 4838"/>
             </a:avLst>
           </a:prstGeom>
           <a:solidFill>
@@ -9473,7 +9482,7 @@
         <p:spPr>
           <a:xfrm>
             <a:off x="3621024" y="2185416"/>
-            <a:ext cx="5120640" cy="749808"/>
+            <a:ext cx="5120640" cy="822960"/>
           </a:xfrm>
           <a:prstGeom prst="rect">
             <a:avLst/>
@@ -9510,7 +9519,7 @@
                 </a:solidFill>
                 <a:latin typeface="Calibri"/>
               </a:rPr>
-              <a:t>add up all boxes (plain sum); or divide that sum by k, the average number of appearances per bunch in the training trees (global divisor; k = 1.891 for expert boxes, 1.793 for detector boxes).</a:t>
+              <a:t>add up all boxes (plain sum); or divide that sum by k, the number of boxes per true bunch in the training trees (global divisor; k = 1.891 for expert boxes, 1.793 for detector boxes).</a:t>
             </a:r>
           </a:p>
           <a:p>
@@ -9529,7 +9538,7 @@
                 </a:solidFill>
                 <a:latin typeface="Calibri"/>
               </a:rPr>
-              <a:t>5 regression models, trained on 716 trees: </a:t>
+              <a:t>5 regression models: </a:t>
             </a:r>
             <a:r>
               <a:rPr sz="950" b="0">
@@ -9538,7 +9547,7 @@
                 </a:solidFill>
                 <a:latin typeface="Calibri"/>
               </a:rPr>
-              <a:t>Linear, Ridge, ElasticNet, SVM, Random Forest.</a:t>
+              <a:t>Linear, Ridge, ElasticNet, SVM, Random Forest. Each is fitted on the 716 training trees, separately for expert boxes and for detector boxes.</a:t>
             </a:r>
           </a:p>
         </p:txBody>
@@ -9551,12 +9560,12 @@
         </p:nvSpPr>
         <p:spPr>
           <a:xfrm>
-            <a:off x="3246120" y="2999232"/>
-            <a:ext cx="5577840" cy="1005840"/>
+            <a:off x="3246120" y="3072384"/>
+            <a:ext cx="5577840" cy="932688"/>
           </a:xfrm>
           <a:prstGeom prst="roundRect">
             <a:avLst>
-              <a:gd name="adj" fmla="val 5454"/>
+              <a:gd name="adj" fmla="val 5882"/>
             </a:avLst>
           </a:prstGeom>
           <a:solidFill>
@@ -9597,7 +9606,7 @@
         </p:nvSpPr>
         <p:spPr>
           <a:xfrm>
-            <a:off x="3319272" y="3063239"/>
+            <a:off x="3319272" y="3136391"/>
             <a:ext cx="237744" cy="237744"/>
           </a:xfrm>
           <a:prstGeom prst="ellipse">
@@ -9641,7 +9650,7 @@
         </p:nvSpPr>
         <p:spPr>
           <a:xfrm>
-            <a:off x="3319272" y="3063239"/>
+            <a:off x="3319272" y="3136391"/>
             <a:ext cx="237744" cy="237744"/>
           </a:xfrm>
           <a:prstGeom prst="rect">
@@ -9683,7 +9692,7 @@
         </p:nvSpPr>
         <p:spPr>
           <a:xfrm>
-            <a:off x="3621024" y="3063239"/>
+            <a:off x="3621024" y="3136391"/>
             <a:ext cx="5029200" cy="237744"/>
           </a:xfrm>
           <a:prstGeom prst="rect">
@@ -9725,7 +9734,7 @@
         </p:nvSpPr>
         <p:spPr>
           <a:xfrm>
-            <a:off x="3621024" y="3300984"/>
+            <a:off x="3621024" y="3346704"/>
             <a:ext cx="3017520" cy="676656"/>
           </a:xfrm>
           <a:prstGeom prst="rect">
@@ -9805,7 +9814,7 @@
           <p:nvPr/>
         </p:nvGraphicFramePr>
         <p:xfrm>
-          <a:off x="6675120" y="3063240"/>
+          <a:off x="6675120" y="3127248"/>
           <a:ext cx="2011680" cy="548640"/>
         </p:xfrm>
         <a:graphic>
@@ -10319,8 +10328,8 @@
         </p:nvSpPr>
         <p:spPr>
           <a:xfrm>
-            <a:off x="6675120" y="3630168"/>
-            <a:ext cx="2057400" cy="365760"/>
+            <a:off x="6675120" y="3685032"/>
+            <a:ext cx="2057400" cy="320040"/>
           </a:xfrm>
           <a:prstGeom prst="rect">
             <a:avLst/>
@@ -10665,13 +10674,13 @@
               </a:spcAft>
             </a:pPr>
             <a:r>
-              <a:rPr sz="1050" b="1">
+              <a:rPr sz="1000" b="1">
                 <a:solidFill>
                   <a:srgbClr val="FFFFFF"/>
                 </a:solidFill>
                 <a:latin typeface="Calibri"/>
               </a:rPr>
-              <a:t>Same counter, different boxes: the drop in accuracy comes from the detector errors.</a:t>
+              <a:t>Same method, different boxes: the accuracy drop shows the effect of detector errors.</a:t>
             </a:r>
           </a:p>
         </p:txBody>
@@ -10922,12 +10931,12 @@
         </p:nvSpPr>
         <p:spPr>
           <a:xfrm>
-            <a:off x="320040" y="658368"/>
-            <a:ext cx="2057400" cy="658368"/>
+            <a:off x="320040" y="640080"/>
+            <a:ext cx="1627632" cy="548640"/>
           </a:xfrm>
           <a:prstGeom prst="roundRect">
             <a:avLst>
-              <a:gd name="adj" fmla="val 8333"/>
+              <a:gd name="adj" fmla="val 10000"/>
             </a:avLst>
           </a:prstGeom>
           <a:solidFill>
@@ -10968,8 +10977,8 @@
         </p:nvSpPr>
         <p:spPr>
           <a:xfrm>
-            <a:off x="374904" y="676656"/>
-            <a:ext cx="1947672" cy="621792"/>
+            <a:off x="347472" y="640080"/>
+            <a:ext cx="1572768" cy="548640"/>
           </a:xfrm>
           <a:prstGeom prst="rect">
             <a:avLst/>
@@ -10991,13 +11000,13 @@
               </a:spcAft>
             </a:pPr>
             <a:r>
-              <a:rPr sz="850" b="0">
+              <a:rPr sz="800" b="0">
                 <a:solidFill>
                   <a:srgbClr val="5B6B62"/>
                 </a:solidFill>
                 <a:latin typeface="Calibri"/>
               </a:rPr>
-              <a:t>Class ±1, best: ground truth → detector</a:t>
+              <a:t>Class ±1, best result</a:t>
             </a:r>
           </a:p>
           <a:p>
@@ -11010,7 +11019,7 @@
               </a:spcAft>
             </a:pPr>
             <a:r>
-              <a:rPr sz="1600" b="1">
+              <a:rPr sz="1400" b="1">
                 <a:solidFill>
                   <a:srgbClr val="1E2B24"/>
                 </a:solidFill>
@@ -11029,13 +11038,13 @@
               </a:spcAft>
             </a:pPr>
             <a:r>
-              <a:rPr sz="800" b="0">
+              <a:rPr sz="750" b="0">
                 <a:solidFill>
                   <a:srgbClr val="5B6B62"/>
                 </a:solidFill>
                 <a:latin typeface="Calibri"/>
               </a:rPr>
-              <a:t>best counter on each kind of boxes</a:t>
+              <a:t>ground truth → detector (table A)</a:t>
             </a:r>
           </a:p>
         </p:txBody>
@@ -11048,12 +11057,12 @@
         </p:nvSpPr>
         <p:spPr>
           <a:xfrm>
-            <a:off x="2468880" y="658368"/>
-            <a:ext cx="2057400" cy="658368"/>
+            <a:off x="2039112" y="640080"/>
+            <a:ext cx="1627632" cy="548640"/>
           </a:xfrm>
           <a:prstGeom prst="roundRect">
             <a:avLst>
-              <a:gd name="adj" fmla="val 8333"/>
+              <a:gd name="adj" fmla="val 10000"/>
             </a:avLst>
           </a:prstGeom>
           <a:solidFill>
@@ -11094,8 +11103,8 @@
         </p:nvSpPr>
         <p:spPr>
           <a:xfrm>
-            <a:off x="2523744" y="676656"/>
-            <a:ext cx="1947672" cy="621792"/>
+            <a:off x="2066543" y="640080"/>
+            <a:ext cx="1572768" cy="548640"/>
           </a:xfrm>
           <a:prstGeom prst="rect">
             <a:avLst/>
@@ -11117,13 +11126,13 @@
               </a:spcAft>
             </a:pPr>
             <a:r>
-              <a:rPr sz="850" b="0">
+              <a:rPr sz="800" b="0">
                 <a:solidFill>
                   <a:srgbClr val="5B6B62"/>
                 </a:solidFill>
                 <a:latin typeface="Calibri"/>
               </a:rPr>
-              <a:t>Tree ±1, best: ground truth → detector</a:t>
+              <a:t>Tree ±1, best result</a:t>
             </a:r>
           </a:p>
           <a:p>
@@ -11136,7 +11145,7 @@
               </a:spcAft>
             </a:pPr>
             <a:r>
-              <a:rPr sz="1600" b="1">
+              <a:rPr sz="1400" b="1">
                 <a:solidFill>
                   <a:srgbClr val="1E2B24"/>
                 </a:solidFill>
@@ -11155,13 +11164,13 @@
               </a:spcAft>
             </a:pPr>
             <a:r>
-              <a:rPr sz="800" b="0">
+              <a:rPr sz="750" b="0">
                 <a:solidFill>
                   <a:srgbClr val="5B6B62"/>
                 </a:solidFill>
                 <a:latin typeface="Calibri"/>
               </a:rPr>
-              <a:t>trees with all four classes right</a:t>
+              <a:t>ground truth → detector (table A)</a:t>
             </a:r>
           </a:p>
         </p:txBody>
@@ -11174,12 +11183,12 @@
         </p:nvSpPr>
         <p:spPr>
           <a:xfrm>
-            <a:off x="4617720" y="658368"/>
-            <a:ext cx="2057400" cy="658368"/>
+            <a:off x="3758183" y="640080"/>
+            <a:ext cx="1627632" cy="548640"/>
           </a:xfrm>
           <a:prstGeom prst="roundRect">
             <a:avLst>
-              <a:gd name="adj" fmla="val 8333"/>
+              <a:gd name="adj" fmla="val 10000"/>
             </a:avLst>
           </a:prstGeom>
           <a:solidFill>
@@ -11220,8 +11229,8 @@
         </p:nvSpPr>
         <p:spPr>
           <a:xfrm>
-            <a:off x="4672583" y="676656"/>
-            <a:ext cx="1947672" cy="621792"/>
+            <a:off x="3785615" y="640080"/>
+            <a:ext cx="1572768" cy="548640"/>
           </a:xfrm>
           <a:prstGeom prst="rect">
             <a:avLst/>
@@ -11243,13 +11252,13 @@
               </a:spcAft>
             </a:pPr>
             <a:r>
-              <a:rPr sz="850" b="0">
+              <a:rPr sz="800" b="0">
                 <a:solidFill>
                   <a:srgbClr val="5B6B62"/>
                 </a:solidFill>
                 <a:latin typeface="Calibri"/>
               </a:rPr>
-              <a:t>Loss caused by the detector boxes</a:t>
+              <a:t>Class ±1 gap, best vs best</a:t>
             </a:r>
           </a:p>
           <a:p>
@@ -11262,7 +11271,7 @@
               </a:spcAft>
             </a:pPr>
             <a:r>
-              <a:rPr sz="1600" b="1">
+              <a:rPr sz="1400" b="1">
                 <a:solidFill>
                   <a:srgbClr val="C8511B"/>
                 </a:solidFill>
@@ -11281,7 +11290,7 @@
               </a:spcAft>
             </a:pPr>
             <a:r>
-              <a:rPr sz="800" b="0">
+              <a:rPr sz="750" b="0">
                 <a:solidFill>
                   <a:srgbClr val="5B6B62"/>
                 </a:solidFill>
@@ -11300,12 +11309,138 @@
         </p:nvSpPr>
         <p:spPr>
           <a:xfrm>
-            <a:off x="6766560" y="658368"/>
-            <a:ext cx="2057400" cy="658368"/>
+            <a:off x="5477255" y="640080"/>
+            <a:ext cx="1627632" cy="548640"/>
           </a:xfrm>
           <a:prstGeom prst="roundRect">
             <a:avLst>
-              <a:gd name="adj" fmla="val 8333"/>
+              <a:gd name="adj" fmla="val 10000"/>
+            </a:avLst>
+          </a:prstGeom>
+          <a:solidFill>
+            <a:srgbClr val="FBEDE5"/>
+          </a:solidFill>
+          <a:ln>
+            <a:noFill/>
+          </a:ln>
+          <a:effectLst/>
+        </p:spPr>
+        <p:style>
+          <a:lnRef idx="1">
+            <a:schemeClr val="accent1"/>
+          </a:lnRef>
+          <a:fillRef idx="3">
+            <a:schemeClr val="accent1"/>
+          </a:fillRef>
+          <a:effectRef idx="2">
+            <a:schemeClr val="accent1"/>
+          </a:effectRef>
+          <a:fontRef idx="minor">
+            <a:schemeClr val="lt1"/>
+          </a:fontRef>
+        </p:style>
+        <p:txBody>
+          <a:bodyPr rtlCol="0" anchor="ctr"/>
+          <a:lstStyle/>
+          <a:p>
+            <a:pPr algn="ctr"/>
+          </a:p>
+        </p:txBody>
+      </p:sp>
+      <p:sp>
+        <p:nvSpPr>
+          <p:cNvPr id="14" name="TextBox 13"/>
+          <p:cNvSpPr txBox="1"/>
+          <p:nvPr/>
+        </p:nvSpPr>
+        <p:spPr>
+          <a:xfrm>
+            <a:off x="5504688" y="640080"/>
+            <a:ext cx="1572768" cy="548640"/>
+          </a:xfrm>
+          <a:prstGeom prst="rect">
+            <a:avLst/>
+          </a:prstGeom>
+          <a:noFill/>
+        </p:spPr>
+        <p:txBody>
+          <a:bodyPr wrap="square" lIns="27432" rIns="27432" tIns="27432" bIns="27432" anchor="ctr">
+            <a:noAutofit/>
+          </a:bodyPr>
+          <a:lstStyle/>
+          <a:p>
+            <a:pPr algn="ctr">
+              <a:spcBef>
+                <a:spcPts val="0"/>
+              </a:spcBef>
+              <a:spcAft>
+                <a:spcPts val="0"/>
+              </a:spcAft>
+            </a:pPr>
+            <a:r>
+              <a:rPr sz="800" b="0">
+                <a:solidFill>
+                  <a:srgbClr val="5B6B62"/>
+                </a:solidFill>
+                <a:latin typeface="Calibri"/>
+              </a:rPr>
+              <a:t>Class ±1 gap, same counter</a:t>
+            </a:r>
+          </a:p>
+          <a:p>
+            <a:pPr algn="ctr">
+              <a:spcBef>
+                <a:spcPts val="0"/>
+              </a:spcBef>
+              <a:spcAft>
+                <a:spcPts val="0"/>
+              </a:spcAft>
+            </a:pPr>
+            <a:r>
+              <a:rPr sz="1400" b="1">
+                <a:solidFill>
+                  <a:srgbClr val="C8511B"/>
+                </a:solidFill>
+                <a:latin typeface="Cambria"/>
+              </a:rPr>
+              <a:t>21.63 pp</a:t>
+            </a:r>
+          </a:p>
+          <a:p>
+            <a:pPr algn="ctr">
+              <a:spcBef>
+                <a:spcPts val="0"/>
+              </a:spcBef>
+              <a:spcAft>
+                <a:spcPts val="0"/>
+              </a:spcAft>
+            </a:pPr>
+            <a:r>
+              <a:rPr sz="750" b="0">
+                <a:solidFill>
+                  <a:srgbClr val="5B6B62"/>
+                </a:solidFill>
+                <a:latin typeface="Calibri"/>
+              </a:rPr>
+              <a:t>ElasticNet on F0; CI 18.44 to 25.00</a:t>
+            </a:r>
+          </a:p>
+        </p:txBody>
+      </p:sp>
+      <p:sp>
+        <p:nvSpPr>
+          <p:cNvPr id="15" name="Rounded Rectangle 14"/>
+          <p:cNvSpPr/>
+          <p:nvPr/>
+        </p:nvSpPr>
+        <p:spPr>
+          <a:xfrm>
+            <a:off x="7196327" y="640080"/>
+            <a:ext cx="1627632" cy="548640"/>
+          </a:xfrm>
+          <a:prstGeom prst="roundRect">
+            <a:avLst>
+              <a:gd name="adj" fmla="val 10000"/>
             </a:avLst>
           </a:prstGeom>
           <a:solidFill>
@@ -11340,14 +11475,14 @@
       </p:sp>
       <p:sp>
         <p:nvSpPr>
-          <p:cNvPr id="14" name="TextBox 13"/>
+          <p:cNvPr id="16" name="TextBox 15"/>
           <p:cNvSpPr txBox="1"/>
           <p:nvPr/>
         </p:nvSpPr>
         <p:spPr>
           <a:xfrm>
-            <a:off x="6821424" y="676656"/>
-            <a:ext cx="1947672" cy="621792"/>
+            <a:off x="7223759" y="640080"/>
+            <a:ext cx="1572768" cy="548640"/>
           </a:xfrm>
           <a:prstGeom prst="rect">
             <a:avLst/>
@@ -11369,7 +11504,7 @@
               </a:spcAft>
             </a:pPr>
             <a:r>
-              <a:rPr sz="850" b="0">
+              <a:rPr sz="800" b="0">
                 <a:solidFill>
                   <a:srgbClr val="5B6B62"/>
                 </a:solidFill>
@@ -11388,7 +11523,7 @@
               </a:spcAft>
             </a:pPr>
             <a:r>
-              <a:rPr sz="1600" b="1">
+              <a:rPr sz="1400" b="1">
                 <a:solidFill>
                   <a:srgbClr val="1F4D36"/>
                 </a:solidFill>
@@ -11407,26 +11542,26 @@
               </a:spcAft>
             </a:pPr>
             <a:r>
-              <a:rPr sz="800" b="0">
+              <a:rPr sz="750" b="0">
                 <a:solidFill>
                   <a:srgbClr val="5B6B62"/>
                 </a:solidFill>
                 <a:latin typeface="Calibri"/>
               </a:rPr>
-              <a:t>not significant, Holm p = 0.628</a:t>
-            </a:r>
-          </a:p>
-        </p:txBody>
-      </p:sp>
-      <p:sp>
-        <p:nvSpPr>
-          <p:cNvPr id="15" name="TextBox 14"/>
+              <a:t>detector boxes, F0; not significant</a:t>
+            </a:r>
+          </a:p>
+        </p:txBody>
+      </p:sp>
+      <p:sp>
+        <p:nvSpPr>
+          <p:cNvPr id="17" name="TextBox 16"/>
           <p:cNvSpPr txBox="1"/>
           <p:nvPr/>
         </p:nvSpPr>
         <p:spPr>
           <a:xfrm>
-            <a:off x="320040" y="1371600"/>
+            <a:off x="320040" y="1225296"/>
             <a:ext cx="4343400" cy="201168"/>
           </a:xfrm>
           <a:prstGeom prst="rect">
@@ -11455,22 +11590,22 @@
                 </a:solidFill>
                 <a:latin typeface="Calibri"/>
               </a:rPr>
-              <a:t>A · All counters, baseline input F0 (accuracy in %, MAE in bunches)</a:t>
+              <a:t>A · Counters on input F0; last row on full input F_all (%, MAE in bunches)</a:t>
             </a:r>
           </a:p>
         </p:txBody>
       </p:sp>
       <p:graphicFrame>
         <p:nvGraphicFramePr>
-          <p:cNvPr id="16" name="Table 15"/>
+          <p:cNvPr id="18" name="Table 17"/>
           <p:cNvGraphicFramePr>
             <a:graphicFrameLocks noGrp="1"/>
           </p:cNvGraphicFramePr>
           <p:nvPr/>
         </p:nvGraphicFramePr>
         <p:xfrm>
-          <a:off x="320040" y="1581912"/>
-          <a:ext cx="4343400" cy="1604772"/>
+          <a:off x="320040" y="1426464"/>
+          <a:ext cx="4343400" cy="1783080"/>
         </p:xfrm>
         <a:graphic>
           <a:graphicData uri="http://schemas.openxmlformats.org/drawingml/2006/table">
@@ -12416,7 +12551,7 @@
                         </a:spcAft>
                       </a:pPr>
                       <a:r>
-                        <a:rPr sz="900" b="1">
+                        <a:rPr sz="900" b="0">
                           <a:solidFill>
                             <a:srgbClr val="1E2B24"/>
                           </a:solidFill>
@@ -12428,7 +12563,7 @@
                   </a:txBody>
                   <a:tcPr marL="45720" marR="45720" marT="18288" marB="18288" anchor="ctr">
                     <a:solidFill>
-                      <a:srgbClr val="F6D5C2"/>
+                      <a:srgbClr val="EEF4EF"/>
                     </a:solidFill>
                   </a:tcPr>
                 </a:tc>
@@ -12480,7 +12615,7 @@
                         </a:spcAft>
                       </a:pPr>
                       <a:r>
-                        <a:rPr sz="900" b="1">
+                        <a:rPr sz="900" b="0">
                           <a:solidFill>
                             <a:srgbClr val="1E2B24"/>
                           </a:solidFill>
@@ -12492,7 +12627,7 @@
                   </a:txBody>
                   <a:tcPr marL="45720" marR="45720" marT="18288" marB="18288" anchor="ctr">
                     <a:solidFill>
-                      <a:srgbClr val="F6D5C2"/>
+                      <a:srgbClr val="EEF4EF"/>
                     </a:solidFill>
                   </a:tcPr>
                 </a:tc>
@@ -12706,7 +12841,7 @@
                         </a:spcAft>
                       </a:pPr>
                       <a:r>
-                        <a:rPr sz="900" b="1">
+                        <a:rPr sz="900" b="0">
                           <a:solidFill>
                             <a:srgbClr val="1E2B24"/>
                           </a:solidFill>
@@ -12718,7 +12853,7 @@
                   </a:txBody>
                   <a:tcPr marL="45720" marR="45720" marT="18288" marB="18288" anchor="ctr">
                     <a:solidFill>
-                      <a:srgbClr val="F6D5C2"/>
+                      <a:srgbClr val="F7FAF7"/>
                     </a:solidFill>
                   </a:tcPr>
                 </a:tc>
@@ -13126,7 +13261,7 @@
                         </a:spcAft>
                       </a:pPr>
                       <a:r>
-                        <a:rPr sz="900" b="1">
+                        <a:rPr sz="900" b="0">
                           <a:solidFill>
                             <a:srgbClr val="1E2B24"/>
                           </a:solidFill>
@@ -13138,7 +13273,7 @@
                   </a:txBody>
                   <a:tcPr marL="45720" marR="45720" marT="18288" marB="18288" anchor="ctr">
                     <a:solidFill>
-                      <a:srgbClr val="F6D5C2"/>
+                      <a:srgbClr val="F7FAF7"/>
                     </a:solidFill>
                   </a:tcPr>
                 </a:tc>
@@ -13401,20 +13536,198 @@
                   </a:tcPr>
                 </a:tc>
               </a:tr>
+              <a:tr h="178308">
+                <a:tc>
+                  <a:txBody>
+                    <a:bodyPr wrap="square" lIns="45720" rIns="45720" tIns="27432" bIns="27432" anchor="ctr">
+                      <a:noAutofit/>
+                    </a:bodyPr>
+                    <a:lstStyle/>
+                    <a:p>
+                      <a:pPr algn="l">
+                        <a:spcBef>
+                          <a:spcPts val="0"/>
+                        </a:spcBef>
+                        <a:spcAft>
+                          <a:spcPts val="0"/>
+                        </a:spcAft>
+                      </a:pPr>
+                      <a:r>
+                        <a:rPr sz="900" b="1">
+                          <a:solidFill>
+                            <a:srgbClr val="1E2B24"/>
+                          </a:solidFill>
+                          <a:latin typeface="Calibri"/>
+                        </a:rPr>
+                        <a:t>Ridge + F_all</a:t>
+                      </a:r>
+                    </a:p>
+                  </a:txBody>
+                  <a:tcPr marL="45720" marR="45720" marT="18288" marB="18288" anchor="ctr">
+                    <a:solidFill>
+                      <a:srgbClr val="F7FAF7"/>
+                    </a:solidFill>
+                  </a:tcPr>
+                </a:tc>
+                <a:tc gridSpan="3">
+                  <a:txBody>
+                    <a:bodyPr wrap="square" lIns="45720" rIns="45720" tIns="27432" bIns="27432" anchor="ctr">
+                      <a:noAutofit/>
+                    </a:bodyPr>
+                    <a:lstStyle/>
+                    <a:p>
+                      <a:pPr algn="ctr">
+                        <a:spcBef>
+                          <a:spcPts val="0"/>
+                        </a:spcBef>
+                        <a:spcAft>
+                          <a:spcPts val="0"/>
+                        </a:spcAft>
+                      </a:pPr>
+                      <a:r>
+                        <a:rPr sz="800" b="0">
+                          <a:solidFill>
+                            <a:srgbClr val="5B6B62"/>
+                          </a:solidFill>
+                          <a:latin typeface="Calibri"/>
+                        </a:rPr>
+                        <a:t>not run: F_all needs confidence</a:t>
+                      </a:r>
+                    </a:p>
+                  </a:txBody>
+                  <a:tcPr marL="45720" marR="45720" marT="18288" marB="18288" anchor="ctr">
+                    <a:solidFill>
+                      <a:srgbClr val="F7FAF7"/>
+                    </a:solidFill>
+                  </a:tcPr>
+                </a:tc>
+                <a:tc hMerge="1">
+                  <a:txBody>
+                    <a:bodyPr/>
+                    <a:lstStyle/>
+                    <a:p/>
+                  </a:txBody>
+                  <a:tcPr/>
+                </a:tc>
+                <a:tc hMerge="1">
+                  <a:txBody>
+                    <a:bodyPr/>
+                    <a:lstStyle/>
+                    <a:p/>
+                  </a:txBody>
+                  <a:tcPr/>
+                </a:tc>
+                <a:tc>
+                  <a:txBody>
+                    <a:bodyPr wrap="square" lIns="45720" rIns="45720" tIns="27432" bIns="27432" anchor="ctr">
+                      <a:noAutofit/>
+                    </a:bodyPr>
+                    <a:lstStyle/>
+                    <a:p>
+                      <a:pPr algn="ctr">
+                        <a:spcBef>
+                          <a:spcPts val="0"/>
+                        </a:spcBef>
+                        <a:spcAft>
+                          <a:spcPts val="0"/>
+                        </a:spcAft>
+                      </a:pPr>
+                      <a:r>
+                        <a:rPr sz="900" b="1">
+                          <a:solidFill>
+                            <a:srgbClr val="1E2B24"/>
+                          </a:solidFill>
+                          <a:latin typeface="Calibri"/>
+                        </a:rPr>
+                        <a:t>77.48</a:t>
+                      </a:r>
+                    </a:p>
+                  </a:txBody>
+                  <a:tcPr marL="45720" marR="45720" marT="18288" marB="18288" anchor="ctr">
+                    <a:solidFill>
+                      <a:srgbClr val="F6D5C2"/>
+                    </a:solidFill>
+                  </a:tcPr>
+                </a:tc>
+                <a:tc>
+                  <a:txBody>
+                    <a:bodyPr wrap="square" lIns="45720" rIns="45720" tIns="27432" bIns="27432" anchor="ctr">
+                      <a:noAutofit/>
+                    </a:bodyPr>
+                    <a:lstStyle/>
+                    <a:p>
+                      <a:pPr algn="ctr">
+                        <a:spcBef>
+                          <a:spcPts val="0"/>
+                        </a:spcBef>
+                        <a:spcAft>
+                          <a:spcPts val="0"/>
+                        </a:spcAft>
+                      </a:pPr>
+                      <a:r>
+                        <a:rPr sz="900" b="1">
+                          <a:solidFill>
+                            <a:srgbClr val="1E2B24"/>
+                          </a:solidFill>
+                          <a:latin typeface="Calibri"/>
+                        </a:rPr>
+                        <a:t>32.62</a:t>
+                      </a:r>
+                    </a:p>
+                  </a:txBody>
+                  <a:tcPr marL="45720" marR="45720" marT="18288" marB="18288" anchor="ctr">
+                    <a:solidFill>
+                      <a:srgbClr val="F6D5C2"/>
+                    </a:solidFill>
+                  </a:tcPr>
+                </a:tc>
+                <a:tc>
+                  <a:txBody>
+                    <a:bodyPr wrap="square" lIns="45720" rIns="45720" tIns="27432" bIns="27432" anchor="ctr">
+                      <a:noAutofit/>
+                    </a:bodyPr>
+                    <a:lstStyle/>
+                    <a:p>
+                      <a:pPr algn="ctr">
+                        <a:spcBef>
+                          <a:spcPts val="0"/>
+                        </a:spcBef>
+                        <a:spcAft>
+                          <a:spcPts val="0"/>
+                        </a:spcAft>
+                      </a:pPr>
+                      <a:r>
+                        <a:rPr sz="900" b="1">
+                          <a:solidFill>
+                            <a:srgbClr val="1E2B24"/>
+                          </a:solidFill>
+                          <a:latin typeface="Calibri"/>
+                        </a:rPr>
+                        <a:t>1.035</a:t>
+                      </a:r>
+                    </a:p>
+                  </a:txBody>
+                  <a:tcPr marL="45720" marR="45720" marT="18288" marB="18288" anchor="ctr">
+                    <a:solidFill>
+                      <a:srgbClr val="F6D5C2"/>
+                    </a:solidFill>
+                  </a:tcPr>
+                </a:tc>
+              </a:tr>
             </a:tbl>
           </a:graphicData>
         </a:graphic>
       </p:graphicFrame>
       <p:sp>
         <p:nvSpPr>
-          <p:cNvPr id="17" name="TextBox 16"/>
+          <p:cNvPr id="19" name="TextBox 18"/>
           <p:cNvSpPr txBox="1"/>
           <p:nvPr/>
         </p:nvSpPr>
         <p:spPr>
           <a:xfrm>
-            <a:off x="4846320" y="1371600"/>
-            <a:ext cx="3977639" cy="201168"/>
+            <a:off x="4846320" y="1225296"/>
+            <a:ext cx="2606040" cy="201168"/>
           </a:xfrm>
           <a:prstGeom prst="rect">
             <a:avLst/>
@@ -13442,20 +13755,20 @@
                 </a:solidFill>
                 <a:latin typeface="Calibri"/>
               </a:rPr>
-              <a:t>B · Class ±1 per class (%), loss in red</a:t>
-            </a:r>
-          </a:p>
-        </p:txBody>
-      </p:sp>
-      <p:sp>
-        <p:nvSpPr>
-          <p:cNvPr id="18" name="Rectangle 17"/>
+              <a:t>B · Class ±1 per class, best results (%)</a:t>
+            </a:r>
+          </a:p>
+        </p:txBody>
+      </p:sp>
+      <p:sp>
+        <p:nvSpPr>
+          <p:cNvPr id="20" name="Rectangle 19"/>
           <p:cNvSpPr/>
           <p:nvPr/>
         </p:nvSpPr>
         <p:spPr>
           <a:xfrm>
-            <a:off x="7452360" y="1426464"/>
+            <a:off x="7452360" y="1280160"/>
             <a:ext cx="91440" cy="91440"/>
           </a:xfrm>
           <a:prstGeom prst="rect">
@@ -13493,13 +13806,13 @@
       </p:sp>
       <p:sp>
         <p:nvSpPr>
-          <p:cNvPr id="19" name="TextBox 18"/>
+          <p:cNvPr id="21" name="TextBox 20"/>
           <p:cNvSpPr txBox="1"/>
           <p:nvPr/>
         </p:nvSpPr>
         <p:spPr>
           <a:xfrm>
-            <a:off x="7562088" y="1371600"/>
+            <a:off x="7562088" y="1225296"/>
             <a:ext cx="685800" cy="201168"/>
           </a:xfrm>
           <a:prstGeom prst="rect">
@@ -13535,13 +13848,13 @@
       </p:sp>
       <p:sp>
         <p:nvSpPr>
-          <p:cNvPr id="20" name="Rectangle 19"/>
+          <p:cNvPr id="22" name="Rectangle 21"/>
           <p:cNvSpPr/>
           <p:nvPr/>
         </p:nvSpPr>
         <p:spPr>
           <a:xfrm>
-            <a:off x="8229600" y="1426464"/>
+            <a:off x="8229600" y="1280160"/>
             <a:ext cx="91440" cy="91440"/>
           </a:xfrm>
           <a:prstGeom prst="rect">
@@ -13579,13 +13892,13 @@
       </p:sp>
       <p:sp>
         <p:nvSpPr>
-          <p:cNvPr id="21" name="TextBox 20"/>
+          <p:cNvPr id="23" name="TextBox 22"/>
           <p:cNvSpPr txBox="1"/>
           <p:nvPr/>
         </p:nvSpPr>
         <p:spPr>
           <a:xfrm>
-            <a:off x="8339327" y="1371600"/>
+            <a:off x="8339327" y="1225296"/>
             <a:ext cx="502920" cy="201168"/>
           </a:xfrm>
           <a:prstGeom prst="rect">
@@ -13621,13 +13934,13 @@
       </p:sp>
       <p:sp>
         <p:nvSpPr>
-          <p:cNvPr id="22" name="Rectangle 21"/>
+          <p:cNvPr id="24" name="Rectangle 23"/>
           <p:cNvSpPr/>
           <p:nvPr/>
         </p:nvSpPr>
         <p:spPr>
           <a:xfrm>
-            <a:off x="4928616" y="1883664"/>
+            <a:off x="4928616" y="1755648"/>
             <a:ext cx="301752" cy="932688"/>
           </a:xfrm>
           <a:prstGeom prst="rect">
@@ -13665,13 +13978,13 @@
       </p:sp>
       <p:sp>
         <p:nvSpPr>
-          <p:cNvPr id="23" name="TextBox 22"/>
+          <p:cNvPr id="25" name="TextBox 24"/>
           <p:cNvSpPr txBox="1"/>
           <p:nvPr/>
         </p:nvSpPr>
         <p:spPr>
           <a:xfrm>
-            <a:off x="4873752" y="1700784"/>
+            <a:off x="4873752" y="1572768"/>
             <a:ext cx="411480" cy="182880"/>
           </a:xfrm>
           <a:prstGeom prst="rect">
@@ -13707,13 +14020,13 @@
       </p:sp>
       <p:sp>
         <p:nvSpPr>
-          <p:cNvPr id="24" name="Rectangle 23"/>
+          <p:cNvPr id="26" name="Rectangle 25"/>
           <p:cNvSpPr/>
           <p:nvPr/>
         </p:nvSpPr>
         <p:spPr>
           <a:xfrm>
-            <a:off x="5257800" y="1910152"/>
+            <a:off x="5257800" y="1782136"/>
             <a:ext cx="301752" cy="906199"/>
           </a:xfrm>
           <a:prstGeom prst="rect">
@@ -13751,13 +14064,13 @@
       </p:sp>
       <p:sp>
         <p:nvSpPr>
-          <p:cNvPr id="25" name="TextBox 24"/>
+          <p:cNvPr id="27" name="TextBox 26"/>
           <p:cNvSpPr txBox="1"/>
           <p:nvPr/>
         </p:nvSpPr>
         <p:spPr>
           <a:xfrm>
-            <a:off x="5202936" y="1727272"/>
+            <a:off x="5202936" y="1599256"/>
             <a:ext cx="411480" cy="182880"/>
           </a:xfrm>
           <a:prstGeom prst="rect">
@@ -13793,13 +14106,13 @@
       </p:sp>
       <p:sp>
         <p:nvSpPr>
-          <p:cNvPr id="26" name="TextBox 25"/>
+          <p:cNvPr id="28" name="TextBox 27"/>
           <p:cNvSpPr txBox="1"/>
           <p:nvPr/>
         </p:nvSpPr>
         <p:spPr>
           <a:xfrm>
-            <a:off x="4882896" y="2825496"/>
+            <a:off x="4882896" y="2697479"/>
             <a:ext cx="722376" cy="201168"/>
           </a:xfrm>
           <a:prstGeom prst="rect">
@@ -13835,13 +14148,13 @@
       </p:sp>
       <p:sp>
         <p:nvSpPr>
-          <p:cNvPr id="27" name="TextBox 26"/>
+          <p:cNvPr id="29" name="TextBox 28"/>
           <p:cNvSpPr txBox="1"/>
           <p:nvPr/>
         </p:nvSpPr>
         <p:spPr>
           <a:xfrm>
-            <a:off x="4882896" y="2999232"/>
+            <a:off x="4882896" y="2871216"/>
             <a:ext cx="722376" cy="192024"/>
           </a:xfrm>
           <a:prstGeom prst="rect">
@@ -13877,13 +14190,13 @@
       </p:sp>
       <p:sp>
         <p:nvSpPr>
-          <p:cNvPr id="28" name="Rectangle 27"/>
+          <p:cNvPr id="30" name="Rectangle 29"/>
           <p:cNvSpPr/>
           <p:nvPr/>
         </p:nvSpPr>
         <p:spPr>
           <a:xfrm>
-            <a:off x="5724144" y="1890286"/>
+            <a:off x="5724144" y="1762270"/>
             <a:ext cx="301752" cy="926065"/>
           </a:xfrm>
           <a:prstGeom prst="rect">
@@ -13921,13 +14234,13 @@
       </p:sp>
       <p:sp>
         <p:nvSpPr>
-          <p:cNvPr id="29" name="TextBox 28"/>
+          <p:cNvPr id="31" name="TextBox 30"/>
           <p:cNvSpPr txBox="1"/>
           <p:nvPr/>
         </p:nvSpPr>
         <p:spPr>
           <a:xfrm>
-            <a:off x="5669280" y="1707406"/>
+            <a:off x="5669280" y="1579390"/>
             <a:ext cx="411480" cy="182880"/>
           </a:xfrm>
           <a:prstGeom prst="rect">
@@ -13963,13 +14276,13 @@
       </p:sp>
       <p:sp>
         <p:nvSpPr>
-          <p:cNvPr id="30" name="Rectangle 29"/>
+          <p:cNvPr id="32" name="Rectangle 31"/>
           <p:cNvSpPr/>
           <p:nvPr/>
         </p:nvSpPr>
         <p:spPr>
           <a:xfrm>
-            <a:off x="6053328" y="2042407"/>
+            <a:off x="6053328" y="1914391"/>
             <a:ext cx="301752" cy="773944"/>
           </a:xfrm>
           <a:prstGeom prst="rect">
@@ -14007,13 +14320,13 @@
       </p:sp>
       <p:sp>
         <p:nvSpPr>
-          <p:cNvPr id="31" name="TextBox 30"/>
+          <p:cNvPr id="33" name="TextBox 32"/>
           <p:cNvSpPr txBox="1"/>
           <p:nvPr/>
         </p:nvSpPr>
         <p:spPr>
           <a:xfrm>
-            <a:off x="5998464" y="1859527"/>
+            <a:off x="5998464" y="1731511"/>
             <a:ext cx="411480" cy="182880"/>
           </a:xfrm>
           <a:prstGeom prst="rect">
@@ -14049,13 +14362,13 @@
       </p:sp>
       <p:sp>
         <p:nvSpPr>
-          <p:cNvPr id="32" name="TextBox 31"/>
+          <p:cNvPr id="34" name="TextBox 33"/>
           <p:cNvSpPr txBox="1"/>
           <p:nvPr/>
         </p:nvSpPr>
         <p:spPr>
           <a:xfrm>
-            <a:off x="5678424" y="2825496"/>
+            <a:off x="5678424" y="2697479"/>
             <a:ext cx="722376" cy="201168"/>
           </a:xfrm>
           <a:prstGeom prst="rect">
@@ -14091,13 +14404,13 @@
       </p:sp>
       <p:sp>
         <p:nvSpPr>
-          <p:cNvPr id="33" name="TextBox 32"/>
+          <p:cNvPr id="35" name="TextBox 34"/>
           <p:cNvSpPr txBox="1"/>
           <p:nvPr/>
         </p:nvSpPr>
         <p:spPr>
           <a:xfrm>
-            <a:off x="5678424" y="2999232"/>
+            <a:off x="5678424" y="2871216"/>
             <a:ext cx="722376" cy="192024"/>
           </a:xfrm>
           <a:prstGeom prst="rect">
@@ -14133,13 +14446,13 @@
       </p:sp>
       <p:sp>
         <p:nvSpPr>
-          <p:cNvPr id="34" name="Rectangle 33"/>
+          <p:cNvPr id="36" name="Rectangle 35"/>
           <p:cNvSpPr/>
           <p:nvPr/>
         </p:nvSpPr>
         <p:spPr>
           <a:xfrm>
-            <a:off x="6519672" y="1943169"/>
+            <a:off x="6519672" y="1815153"/>
             <a:ext cx="301752" cy="873182"/>
           </a:xfrm>
           <a:prstGeom prst="rect">
@@ -14177,13 +14490,13 @@
       </p:sp>
       <p:sp>
         <p:nvSpPr>
-          <p:cNvPr id="35" name="TextBox 34"/>
+          <p:cNvPr id="37" name="TextBox 36"/>
           <p:cNvSpPr txBox="1"/>
           <p:nvPr/>
         </p:nvSpPr>
         <p:spPr>
           <a:xfrm>
-            <a:off x="6464808" y="1760289"/>
+            <a:off x="6464808" y="1632273"/>
             <a:ext cx="411480" cy="182880"/>
           </a:xfrm>
           <a:prstGeom prst="rect">
@@ -14219,13 +14532,13 @@
       </p:sp>
       <p:sp>
         <p:nvSpPr>
-          <p:cNvPr id="36" name="Rectangle 35"/>
+          <p:cNvPr id="38" name="Rectangle 37"/>
           <p:cNvSpPr/>
           <p:nvPr/>
         </p:nvSpPr>
         <p:spPr>
           <a:xfrm>
-            <a:off x="6848856" y="2280522"/>
+            <a:off x="6848856" y="2152506"/>
             <a:ext cx="301752" cy="535829"/>
           </a:xfrm>
           <a:prstGeom prst="rect">
@@ -14263,13 +14576,13 @@
       </p:sp>
       <p:sp>
         <p:nvSpPr>
-          <p:cNvPr id="37" name="TextBox 36"/>
+          <p:cNvPr id="39" name="TextBox 38"/>
           <p:cNvSpPr txBox="1"/>
           <p:nvPr/>
         </p:nvSpPr>
         <p:spPr>
           <a:xfrm>
-            <a:off x="6793992" y="2097642"/>
+            <a:off x="6793992" y="1969626"/>
             <a:ext cx="411480" cy="182880"/>
           </a:xfrm>
           <a:prstGeom prst="rect">
@@ -14305,13 +14618,13 @@
       </p:sp>
       <p:sp>
         <p:nvSpPr>
-          <p:cNvPr id="38" name="TextBox 37"/>
+          <p:cNvPr id="40" name="TextBox 39"/>
           <p:cNvSpPr txBox="1"/>
           <p:nvPr/>
         </p:nvSpPr>
         <p:spPr>
           <a:xfrm>
-            <a:off x="6473952" y="2825496"/>
+            <a:off x="6473952" y="2697479"/>
             <a:ext cx="722376" cy="201168"/>
           </a:xfrm>
           <a:prstGeom prst="rect">
@@ -14347,13 +14660,13 @@
       </p:sp>
       <p:sp>
         <p:nvSpPr>
-          <p:cNvPr id="39" name="TextBox 38"/>
+          <p:cNvPr id="41" name="TextBox 40"/>
           <p:cNvSpPr txBox="1"/>
           <p:nvPr/>
         </p:nvSpPr>
         <p:spPr>
           <a:xfrm>
-            <a:off x="6473952" y="2999232"/>
+            <a:off x="6473952" y="2871216"/>
             <a:ext cx="722376" cy="192024"/>
           </a:xfrm>
           <a:prstGeom prst="rect">
@@ -14389,13 +14702,13 @@
       </p:sp>
       <p:sp>
         <p:nvSpPr>
-          <p:cNvPr id="40" name="Rectangle 39"/>
+          <p:cNvPr id="42" name="Rectangle 41"/>
           <p:cNvSpPr/>
           <p:nvPr/>
         </p:nvSpPr>
         <p:spPr>
           <a:xfrm>
-            <a:off x="7315200" y="1890286"/>
+            <a:off x="7315200" y="1762270"/>
             <a:ext cx="301752" cy="926065"/>
           </a:xfrm>
           <a:prstGeom prst="rect">
@@ -14433,13 +14746,13 @@
       </p:sp>
       <p:sp>
         <p:nvSpPr>
-          <p:cNvPr id="41" name="TextBox 40"/>
+          <p:cNvPr id="43" name="TextBox 42"/>
           <p:cNvSpPr txBox="1"/>
           <p:nvPr/>
         </p:nvSpPr>
         <p:spPr>
           <a:xfrm>
-            <a:off x="7260336" y="1707406"/>
+            <a:off x="7260336" y="1579390"/>
             <a:ext cx="411480" cy="182880"/>
           </a:xfrm>
           <a:prstGeom prst="rect">
@@ -14475,13 +14788,13 @@
       </p:sp>
       <p:sp>
         <p:nvSpPr>
-          <p:cNvPr id="42" name="Rectangle 41"/>
+          <p:cNvPr id="44" name="Rectangle 43"/>
           <p:cNvSpPr/>
           <p:nvPr/>
         </p:nvSpPr>
         <p:spPr>
           <a:xfrm>
-            <a:off x="7644383" y="2141645"/>
+            <a:off x="7644383" y="2013629"/>
             <a:ext cx="301752" cy="674706"/>
           </a:xfrm>
           <a:prstGeom prst="rect">
@@ -14519,13 +14832,13 @@
       </p:sp>
       <p:sp>
         <p:nvSpPr>
-          <p:cNvPr id="43" name="TextBox 42"/>
+          <p:cNvPr id="45" name="TextBox 44"/>
           <p:cNvSpPr txBox="1"/>
           <p:nvPr/>
         </p:nvSpPr>
         <p:spPr>
           <a:xfrm>
-            <a:off x="7589519" y="1958765"/>
+            <a:off x="7589519" y="1830749"/>
             <a:ext cx="411480" cy="182880"/>
           </a:xfrm>
           <a:prstGeom prst="rect">
@@ -14561,13 +14874,13 @@
       </p:sp>
       <p:sp>
         <p:nvSpPr>
-          <p:cNvPr id="44" name="TextBox 43"/>
+          <p:cNvPr id="46" name="TextBox 45"/>
           <p:cNvSpPr txBox="1"/>
           <p:nvPr/>
         </p:nvSpPr>
         <p:spPr>
           <a:xfrm>
-            <a:off x="7269480" y="2825496"/>
+            <a:off x="7269480" y="2697479"/>
             <a:ext cx="722376" cy="201168"/>
           </a:xfrm>
           <a:prstGeom prst="rect">
@@ -14603,13 +14916,13 @@
       </p:sp>
       <p:sp>
         <p:nvSpPr>
-          <p:cNvPr id="45" name="TextBox 44"/>
+          <p:cNvPr id="47" name="TextBox 46"/>
           <p:cNvSpPr txBox="1"/>
           <p:nvPr/>
         </p:nvSpPr>
         <p:spPr>
           <a:xfrm>
-            <a:off x="7269480" y="2999232"/>
+            <a:off x="7269480" y="2871216"/>
             <a:ext cx="722376" cy="192024"/>
           </a:xfrm>
           <a:prstGeom prst="rect">
@@ -14645,14 +14958,14 @@
       </p:sp>
       <p:sp>
         <p:nvSpPr>
-          <p:cNvPr id="46" name="Rounded Rectangle 45"/>
+          <p:cNvPr id="48" name="Rounded Rectangle 47"/>
           <p:cNvSpPr/>
           <p:nvPr/>
         </p:nvSpPr>
         <p:spPr>
           <a:xfrm>
-            <a:off x="8046719" y="1609344"/>
-            <a:ext cx="758952" cy="1591056"/>
+            <a:off x="8046719" y="1472184"/>
+            <a:ext cx="758952" cy="1609344"/>
           </a:xfrm>
           <a:prstGeom prst="roundRect">
             <a:avLst>
@@ -14691,13 +15004,13 @@
       </p:sp>
       <p:sp>
         <p:nvSpPr>
-          <p:cNvPr id="47" name="Rectangle 46"/>
+          <p:cNvPr id="49" name="Rectangle 48"/>
           <p:cNvSpPr/>
           <p:nvPr/>
         </p:nvSpPr>
         <p:spPr>
           <a:xfrm>
-            <a:off x="8110727" y="1901851"/>
+            <a:off x="8110727" y="1773835"/>
             <a:ext cx="301752" cy="914500"/>
           </a:xfrm>
           <a:prstGeom prst="rect">
@@ -14735,13 +15048,13 @@
       </p:sp>
       <p:sp>
         <p:nvSpPr>
-          <p:cNvPr id="48" name="TextBox 47"/>
+          <p:cNvPr id="50" name="TextBox 49"/>
           <p:cNvSpPr txBox="1"/>
           <p:nvPr/>
         </p:nvSpPr>
         <p:spPr>
           <a:xfrm>
-            <a:off x="8055863" y="1718971"/>
+            <a:off x="8055863" y="1590955"/>
             <a:ext cx="411480" cy="182880"/>
           </a:xfrm>
           <a:prstGeom prst="rect">
@@ -14777,13 +15090,13 @@
       </p:sp>
       <p:sp>
         <p:nvSpPr>
-          <p:cNvPr id="49" name="Rectangle 48"/>
+          <p:cNvPr id="51" name="Rectangle 50"/>
           <p:cNvSpPr/>
           <p:nvPr/>
         </p:nvSpPr>
         <p:spPr>
           <a:xfrm>
-            <a:off x="8439911" y="2093705"/>
+            <a:off x="8439911" y="1965689"/>
             <a:ext cx="301752" cy="722646"/>
           </a:xfrm>
           <a:prstGeom prst="rect">
@@ -14821,13 +15134,13 @@
       </p:sp>
       <p:sp>
         <p:nvSpPr>
-          <p:cNvPr id="50" name="TextBox 49"/>
+          <p:cNvPr id="52" name="TextBox 51"/>
           <p:cNvSpPr txBox="1"/>
           <p:nvPr/>
         </p:nvSpPr>
         <p:spPr>
           <a:xfrm>
-            <a:off x="8385047" y="1910825"/>
+            <a:off x="8385047" y="1782809"/>
             <a:ext cx="411480" cy="182880"/>
           </a:xfrm>
           <a:prstGeom prst="rect">
@@ -14863,13 +15176,13 @@
       </p:sp>
       <p:sp>
         <p:nvSpPr>
-          <p:cNvPr id="51" name="TextBox 50"/>
+          <p:cNvPr id="53" name="TextBox 52"/>
           <p:cNvSpPr txBox="1"/>
           <p:nvPr/>
         </p:nvSpPr>
         <p:spPr>
           <a:xfrm>
-            <a:off x="8065007" y="2825496"/>
+            <a:off x="8065007" y="2697479"/>
             <a:ext cx="722376" cy="201168"/>
           </a:xfrm>
           <a:prstGeom prst="rect">
@@ -14905,13 +15218,13 @@
       </p:sp>
       <p:sp>
         <p:nvSpPr>
-          <p:cNvPr id="52" name="TextBox 51"/>
+          <p:cNvPr id="54" name="TextBox 53"/>
           <p:cNvSpPr txBox="1"/>
           <p:nvPr/>
         </p:nvSpPr>
         <p:spPr>
           <a:xfrm>
-            <a:off x="8065007" y="2999232"/>
+            <a:off x="8065007" y="2871216"/>
             <a:ext cx="722376" cy="192024"/>
           </a:xfrm>
           <a:prstGeom prst="rect">
@@ -14947,13 +15260,13 @@
       </p:sp>
       <p:sp>
         <p:nvSpPr>
-          <p:cNvPr id="53" name="Rectangle 52"/>
+          <p:cNvPr id="55" name="Rectangle 54"/>
           <p:cNvSpPr/>
           <p:nvPr/>
         </p:nvSpPr>
         <p:spPr>
           <a:xfrm>
-            <a:off x="4846320" y="2816352"/>
+            <a:off x="4846320" y="2688336"/>
             <a:ext cx="3977639" cy="9144"/>
           </a:xfrm>
           <a:prstGeom prst="rect">
@@ -14991,7 +15304,7 @@
       </p:sp>
       <p:sp>
         <p:nvSpPr>
-          <p:cNvPr id="54" name="TextBox 53"/>
+          <p:cNvPr id="56" name="TextBox 55"/>
           <p:cNvSpPr txBox="1"/>
           <p:nvPr/>
         </p:nvSpPr>
@@ -15033,7 +15346,7 @@
       </p:sp>
       <p:graphicFrame>
         <p:nvGraphicFramePr>
-          <p:cNvPr id="55" name="Table 54"/>
+          <p:cNvPr id="57" name="Table 56"/>
           <p:cNvGraphicFramePr>
             <a:graphicFrameLocks noGrp="1"/>
           </p:cNvGraphicFramePr>
@@ -16420,7 +16733,7 @@
       </p:graphicFrame>
       <p:sp>
         <p:nvSpPr>
-          <p:cNvPr id="56" name="TextBox 55"/>
+          <p:cNvPr id="58" name="TextBox 57"/>
           <p:cNvSpPr txBox="1"/>
           <p:nvPr/>
         </p:nvSpPr>
@@ -16525,7 +16838,7 @@
       </p:sp>
       <p:sp>
         <p:nvSpPr>
-          <p:cNvPr id="57" name="TextBox 56"/>
+          <p:cNvPr id="59" name="TextBox 58"/>
           <p:cNvSpPr txBox="1"/>
           <p:nvPr/>
         </p:nvSpPr>
@@ -16560,14 +16873,14 @@
                 </a:solidFill>
                 <a:latin typeface="Calibri"/>
               </a:rPr>
-              <a:t>D · Why the counter cannot repair the detector errors</a:t>
-            </a:r>
-          </a:p>
-        </p:txBody>
-      </p:sp>
-      <p:sp>
-        <p:nvSpPr>
-          <p:cNvPr id="58" name="TextBox 57"/>
+              <a:t>D · Detector errors behind the gap</a:t>
+            </a:r>
+          </a:p>
+        </p:txBody>
+      </p:sp>
+      <p:sp>
+        <p:nvSpPr>
+          <p:cNvPr id="60" name="TextBox 59"/>
           <p:cNvSpPr txBox="1"/>
           <p:nvPr/>
         </p:nvSpPr>
@@ -16661,7 +16974,7 @@
                 </a:solidFill>
                 <a:latin typeface="Calibri"/>
               </a:rPr>
-              <a:t>Full input F_all (67 numbers instead of 13): +1.42 pp, </a:t>
+              <a:t>Full input F_all instead of F0 (Ridge): 76.06 → 77.48, +1.42 pp, </a:t>
             </a:r>
             <a:r>
               <a:rPr sz="900" b="0">
@@ -16677,7 +16990,7 @@
       </p:sp>
       <p:sp>
         <p:nvSpPr>
-          <p:cNvPr id="59" name="TextBox 58"/>
+          <p:cNvPr id="61" name="TextBox 60"/>
           <p:cNvSpPr txBox="1"/>
           <p:nvPr/>
         </p:nvSpPr>
@@ -16712,14 +17025,14 @@
                 </a:solidFill>
                 <a:latin typeface="Calibri"/>
               </a:rPr>
-              <a:t>The loss stays when we change the setup (Class ±1 loss):</a:t>
-            </a:r>
-          </a:p>
-        </p:txBody>
-      </p:sp>
-      <p:sp>
-        <p:nvSpPr>
-          <p:cNvPr id="60" name="Rounded Rectangle 59"/>
+              <a:t>The gap stays in other setups (Class ±1 gap):</a:t>
+            </a:r>
+          </a:p>
+        </p:txBody>
+      </p:sp>
+      <p:sp>
+        <p:nvSpPr>
+          <p:cNvPr id="62" name="Rounded Rectangle 61"/>
           <p:cNvSpPr/>
           <p:nvPr/>
         </p:nvSpPr>
@@ -16765,7 +17078,7 @@
       </p:sp>
       <p:sp>
         <p:nvSpPr>
-          <p:cNvPr id="61" name="TextBox 60"/>
+          <p:cNvPr id="63" name="TextBox 62"/>
           <p:cNvSpPr txBox="1"/>
           <p:nvPr/>
         </p:nvSpPr>
@@ -16826,7 +17139,7 @@
       </p:sp>
       <p:sp>
         <p:nvSpPr>
-          <p:cNvPr id="62" name="Rounded Rectangle 61"/>
+          <p:cNvPr id="64" name="Rounded Rectangle 63"/>
           <p:cNvSpPr/>
           <p:nvPr/>
         </p:nvSpPr>
@@ -16872,7 +17185,7 @@
       </p:sp>
       <p:sp>
         <p:nvSpPr>
-          <p:cNvPr id="63" name="TextBox 62"/>
+          <p:cNvPr id="65" name="TextBox 64"/>
           <p:cNvSpPr txBox="1"/>
           <p:nvPr/>
         </p:nvSpPr>
@@ -16933,7 +17246,7 @@
       </p:sp>
       <p:sp>
         <p:nvSpPr>
-          <p:cNvPr id="64" name="Rounded Rectangle 63"/>
+          <p:cNvPr id="66" name="Rounded Rectangle 65"/>
           <p:cNvSpPr/>
           <p:nvPr/>
         </p:nvSpPr>
@@ -16979,7 +17292,7 @@
       </p:sp>
       <p:sp>
         <p:nvSpPr>
-          <p:cNvPr id="65" name="TextBox 64"/>
+          <p:cNvPr id="67" name="TextBox 66"/>
           <p:cNvSpPr txBox="1"/>
           <p:nvPr/>
         </p:nvSpPr>
@@ -17040,7 +17353,7 @@
       </p:sp>
       <p:sp>
         <p:nvSpPr>
-          <p:cNvPr id="66" name="Rounded Rectangle 65"/>
+          <p:cNvPr id="68" name="Rounded Rectangle 67"/>
           <p:cNvSpPr/>
           <p:nvPr/>
         </p:nvSpPr>
@@ -17086,7 +17399,7 @@
       </p:sp>
       <p:sp>
         <p:nvSpPr>
-          <p:cNvPr id="67" name="TextBox 66"/>
+          <p:cNvPr id="69" name="TextBox 68"/>
           <p:cNvSpPr txBox="1"/>
           <p:nvPr/>
         </p:nvSpPr>
@@ -17552,7 +17865,7 @@
                 </a:solidFill>
                 <a:latin typeface="Calibri"/>
               </a:rPr>
-              <a:t>The quality of the boxes matters most.</a:t>
+              <a:t>Box quality changes the result far more than the counter.</a:t>
             </a:r>
           </a:p>
           <a:p>
@@ -17571,7 +17884,7 @@
                 </a:solidFill>
                 <a:latin typeface="Calibri"/>
               </a:rPr>
-              <a:t>Ground-truth boxes give 20.57 pp more Class ±1 and 59.57 pp more Tree ±1 than detector boxes. The five counters differ by at most 3.19 pp, which is not significant.</a:t>
+              <a:t>Best result with ground-truth boxes against best result with detector boxes: 20.57 pp more Class ±1 and 59.57 pp more Tree ±1. On detector boxes, the five regression counters differ by at most 3.19 pp, not significant.</a:t>
             </a:r>
           </a:p>
         </p:txBody>
@@ -17745,7 +18058,7 @@
                 </a:solidFill>
                 <a:latin typeface="Calibri"/>
               </a:rPr>
-              <a:t>The gap is stable.</a:t>
+              <a:t>The gap persists in other setups.</a:t>
             </a:r>
           </a:p>
           <a:p>
@@ -17764,7 +18077,7 @@
                 </a:solidFill>
                 <a:latin typeface="Calibri"/>
               </a:rPr>
-              <a:t>It stays between 23 and 25 pp with validation-based selection, cross-validation, a YOLO11m detector and four YOLO26 checkpoints.</a:t>
+              <a:t>It is 23 to 25 pp with validation-based selection, cross-validation, a YOLO11m detector and four YOLO26 checkpoints.</a:t>
             </a:r>
           </a:p>
         </p:txBody>
@@ -17957,7 +18270,7 @@
                 </a:solidFill>
                 <a:latin typeface="Calibri"/>
               </a:rPr>
-              <a:t>B3 −36.17 pp, B4 −26.95 pp, B2 −16.31 pp, B1 −2.84 pp. The detector must find more B3 and B4 bunches and separate B2 from B3.</a:t>
+              <a:t>B3 −36.17 pp, B4 −26.95 pp, B2 −16.31 pp, B1 −2.84 pp. The results support better detection of B3 and B4 and better separation of B2 from B3.</a:t>
             </a:r>
           </a:p>
         </p:txBody>
@@ -18633,13 +18946,13 @@
               </a:spcAft>
             </a:pPr>
             <a:r>
-              <a:rPr sz="1250" b="0">
+              <a:rPr sz="1150" b="0">
                 <a:solidFill>
                   <a:srgbClr val="FFFFFF"/>
                 </a:solidFill>
                 <a:latin typeface="Calibri"/>
               </a:rPr>
-              <a:t>On SawitMVC, the count depends far more on the detector output than on the choice of counter.</a:t>
+              <a:t>On SawitMVC, the quality of the boxes changed the accuracy far more than the choice among the counters we compared.</a:t>
             </a:r>
           </a:p>
         </p:txBody>

</xml_diff>